<commit_message>
Add French and Italian; replace Cloudron with 'Contact us': hosted by us or self-hosted, export in many formats, your data is yours
Co-Authored-By: Claude Opus 5.5 <noreply@anthropic.com>
</commit_message>
<xml_diff>
--- a/spacerisk/materials/de/spacerisk-sales-deck.pptx
+++ b/spacerisk/materials/de/spacerisk-sales-deck.pptx
@@ -3745,7 +3745,7 @@
               </a:defRPr>
             </a:pPr>
             <a:r>
-              <a:t>Loslegen</a:t>
+              <a:t>Kontaktieren Sie uns</a:t>
             </a:r>
           </a:p>
         </p:txBody>
@@ -3828,7 +3828,7 @@
               </a:defRPr>
             </a:pPr>
             <a:r>
-              <a:t>Selbst gehostet auf Cloudron</a:t>
+              <a:t>Wir hosten SpaceRisk für Sie — oder Sie hosten es selbst</a:t>
             </a:r>
           </a:p>
         </p:txBody>
@@ -3911,7 +3911,7 @@
               </a:defRPr>
             </a:pPr>
             <a:r>
-              <a:t>Ihre Daten bleiben bei Ihnen</a:t>
+              <a:t>Exportieren Sie Ihre Daten in vielen Formaten: PDF, PowerPoint, Excel und vollständige Datenbank-Backups</a:t>
             </a:r>
           </a:p>
         </p:txBody>
@@ -3994,7 +3994,90 @@
               </a:defRPr>
             </a:pPr>
             <a:r>
-              <a:t>Laden Sie ein Beispielunternehmen und holen Sie Ihre Teams noch heute dazu</a:t>
+              <a:t>Ihre Daten gehören Ihnen</a:t>
+            </a:r>
+          </a:p>
+        </p:txBody>
+      </p:sp>
+      <p:sp>
+        <p:nvSpPr>
+          <p:cNvPr id="10" name="Rounded Rectangle 9"/>
+          <p:cNvSpPr/>
+          <p:nvPr/>
+        </p:nvSpPr>
+        <p:spPr>
+          <a:xfrm>
+            <a:off x="640080" y="4892040"/>
+            <a:ext cx="10881360" cy="868680"/>
+          </a:xfrm>
+          <a:prstGeom prst="roundRect">
+            <a:avLst/>
+          </a:prstGeom>
+          <a:solidFill>
+            <a:srgbClr val="F6F8FC"/>
+          </a:solidFill>
+          <a:ln>
+            <a:solidFill>
+              <a:srgbClr val="F97362"/>
+            </a:solidFill>
+          </a:ln>
+        </p:spPr>
+        <p:style>
+          <a:lnRef idx="1">
+            <a:schemeClr val="accent1"/>
+          </a:lnRef>
+          <a:fillRef idx="3">
+            <a:schemeClr val="accent1"/>
+          </a:fillRef>
+          <a:effectRef idx="2">
+            <a:schemeClr val="accent1"/>
+          </a:effectRef>
+          <a:fontRef idx="minor">
+            <a:schemeClr val="lt1"/>
+          </a:fontRef>
+        </p:style>
+        <p:txBody>
+          <a:bodyPr rtlCol="0" anchor="ctr"/>
+          <a:lstStyle/>
+          <a:p>
+            <a:pPr algn="ctr"/>
+          </a:p>
+        </p:txBody>
+      </p:sp>
+      <p:sp>
+        <p:nvSpPr>
+          <p:cNvPr id="11" name="TextBox 10"/>
+          <p:cNvSpPr txBox="1"/>
+          <p:nvPr/>
+        </p:nvSpPr>
+        <p:spPr>
+          <a:xfrm>
+            <a:off x="914400" y="5029200"/>
+            <a:ext cx="10424160" cy="731520"/>
+          </a:xfrm>
+          <a:prstGeom prst="rect">
+            <a:avLst/>
+          </a:prstGeom>
+          <a:noFill/>
+        </p:spPr>
+        <p:txBody>
+          <a:bodyPr wrap="square">
+            <a:spAutoFit/>
+          </a:bodyPr>
+          <a:lstStyle/>
+          <a:p>
+            <a:pPr>
+              <a:spcAft>
+                <a:spcPts val="1000"/>
+              </a:spcAft>
+              <a:defRPr sz="2000" b="0">
+                <a:solidFill>
+                  <a:srgbClr val="26314D"/>
+                </a:solidFill>
+              </a:defRPr>
+            </a:pPr>
+            <a:r>
+              <a:t>thomas.frivold@frivolddigital.com</a:t>
             </a:r>
           </a:p>
         </p:txBody>

</xml_diff>